<commit_message>
Merge lane/backend: the log range halving test
</commit_message>
<xml_diff>
--- a/docs/deck/amanah-deck.pptx
+++ b/docs/deck/amanah-deck.pptx
@@ -652,7 +652,7 @@
           <a:lstStyle/>
           <a:p>
             <a:r>
-              <a:t>Amanah is fund-agnostic: a programme's rules live in its on-chain mandate, so the same wallet serves zakat, waqf, charity, humanitarian cash or a government transfer. The demo runs three funds side by side. The build has 289 automated tests across five suites. A pilot needs one programme at a Malaysian zakat institution, agent keys in a key management service, and trustee governance in a Safe multisig. After that come attested lineage, so the registry can prove which model signed, and a permissioned chain for institutions that need one. The design maps to China's 2026 agent-payment convention: authorisation boundaries, limits, Know Your Agent, security testing and a human fallback.</a:t>
+              <a:t>Amanah is fund-agnostic: a programme's rules live in its on-chain mandate, so the same wallet serves zakat, waqf, charity, humanitarian cash or a government transfer. The demo runs three funds side by side. The build has 290 automated tests across five suites. A pilot needs one programme at a Malaysian zakat institution, agent keys in a key management service, and trustee governance in a Safe multisig. After that come attested lineage, so the registry can prove which model signed, and a permissioned chain for institutions that need one. The design maps to China's 2026 agent-payment convention: authorisation boundaries, limits, Know Your Agent, security testing and a human fallback.</a:t>
             </a:r>
           </a:p>
         </p:txBody>
@@ -7180,7 +7180,7 @@
                 </a:solidFill>
                 <a:latin typeface="Arial"/>
               </a:rPr>
-              <a:t>289 automated tests: contracts 109, backend 116, red team 24, frontend unit 23, browser checks 17</a:t>
+              <a:t>290 automated tests: contracts 109, backend 117, red team 24, frontend unit 23, browser checks 17</a:t>
             </a:r>
           </a:p>
         </p:txBody>

</xml_diff>

<commit_message>
Fix the second review's findings in the release scripts
</commit_message>
<xml_diff>
--- a/docs/deck/amanah-deck.pptx
+++ b/docs/deck/amanah-deck.pptx
@@ -512,7 +512,7 @@
           <a:lstStyle/>
           <a:p>
             <a:r>
-              <a:t>Amanah is an agent wallet for money held in trust: zakat, charity, humanitarian cash and public subsidies. It pays beneficiaries on its own, on a public chain. Our claim is that no single persuaded model can make it pay. In our red team, [[fill: S1 %]] of attacks got the planner alone, which is how a typical agent wallet works, to sign a bad payment. Through Amanah's quorum and contract, [[fill: attacks that moved funds]] moved any funds. Amanah is the Arabic word for a trust held on behalf of others. The rest of this deck shows how the wallet carries that duty, and how you can check each number yourself.</a:t>
+              <a:t>Amanah is an agent wallet for money held in trust: zakat, charity, humanitarian cash and public subsidies. It pays beneficiaries on its own, on a public chain. Our claim is that no single persuaded model can make it pay. In our red team, [[fill: S1 % of payment attacks]] of the attacks that asked for a payment got the planner alone, which is how a typical agent wallet works, to sign it. Through Amanah's quorum and contract, [[fill: attacks that moved funds]] moved any funds. Amanah is the Arabic word for a trust held on behalf of others. The rest of this deck shows how the wallet carries that duty, and how you can check each number yourself.</a:t>
             </a:r>
           </a:p>
         </p:txBody>
@@ -652,7 +652,7 @@
           <a:lstStyle/>
           <a:p>
             <a:r>
-              <a:t>Amanah is fund-agnostic: a programme's rules live in its on-chain mandate, so the same wallet serves zakat, waqf, charity, humanitarian cash or a government transfer. The demo runs three funds side by side. The build has 297 automated tests across five suites. A pilot needs one programme at a Malaysian zakat institution, agent keys in a key management service, and trustee governance in a Safe multisig. After that come attested lineage, so the registry can prove which model signed, and a permissioned chain for institutions that need one. The design maps to China's 2026 agent-payment convention: authorisation boundaries, limits, Know Your Agent, security testing and a human fallback.</a:t>
+              <a:t>Amanah is fund-agnostic: a programme's rules live in its on-chain mandate, so the same wallet serves zakat, waqf, charity, humanitarian cash or a government transfer. The demo runs three funds side by side. The build has 306 automated tests across five suites. A pilot needs one programme at a Malaysian zakat institution, agent keys in a key management service, and trustee governance in a Safe multisig. After that come attested lineage, so the registry can prove which model signed, and a permissioned chain for institutions that need one. The design maps to China's 2026 agent-payment convention: authorisation boundaries, limits, Know Your Agent, security testing and a human fallback.</a:t>
             </a:r>
           </a:p>
         </p:txBody>
@@ -1212,7 +1212,7 @@
           <a:lstStyle/>
           <a:p>
             <a:r>
-              <a:t>Independence is the whole argument, so we measured it rather than assumed it. We fixed the protocol and committed it before the full run. Each attack ran against five configurations, from the planner alone up to the full quorum and the vault. The planner alone signed [[fill: S1 %]] of the attacks. With the Qwen auditor, [[fill: S3 %]]. With the sentinel too, [[fill: S4 %]]. Through the vault, [[fill: S5 %]]. The planner and the Qwen auditor failed together on [[fill: joint failure, planner and Qwen auditor]] of transfer attacks. The paired comparisons use exact McNemar tests with Holm's correction, and every rate has a 95% Wilson interval.</a:t>
+              <a:t>Independence is the whole argument, so we measured it rather than assumed it. We fixed the protocol and committed it before the full run. Each attack ran against five configurations, from the planner alone up to the full quorum and the vault. Against the planner alone, [[fill: S1 %]] of the attacks succeeded. With the Qwen auditor, [[fill: S3 %]]. With the sentinel too, [[fill: S4 %]]. Through the vault, [[fill: S5 %]]. The planner and the Qwen auditor failed together on [[fill: joint failure, planner and Qwen auditor]] of transfer attacks. The paired comparisons use exact McNemar tests with Holm's correction, and every rate has a 95% Wilson interval.</a:t>
             </a:r>
           </a:p>
         </p:txBody>
@@ -4552,7 +4552,7 @@
                 </a:solidFill>
                 <a:latin typeface="Arial"/>
               </a:rPr>
-              <a:t>[[fill: S1 %]]</a:t>
+              <a:t>[[fill: S1 % of payment attacks]]</a:t>
             </a:r>
           </a:p>
           <a:p>
@@ -4571,7 +4571,7 @@
                 </a:solidFill>
                 <a:latin typeface="Arial"/>
               </a:rPr>
-              <a:t>of red-team attacks got the planner alone, a typical single-model agent wallet, to sign a bad payment</a:t>
+              <a:t>of red-team payment attacks got the planner alone, a typical single-model agent wallet, to sign a bad payment</a:t>
             </a:r>
           </a:p>
         </p:txBody>
@@ -4676,7 +4676,7 @@
                 </a:solidFill>
                 <a:latin typeface="Arial"/>
               </a:rPr>
-              <a:t>attacks moved any funds through Amanah's quorum and contract, on the same attack set</a:t>
+              <a:t>payment attacks moved any funds through Amanah's quorum and contract, on the same set</a:t>
             </a:r>
           </a:p>
         </p:txBody>
@@ -7180,7 +7180,7 @@
                 </a:solidFill>
                 <a:latin typeface="Arial"/>
               </a:rPr>
-              <a:t>297 automated tests: contracts 109, backend 124, red team 24, frontend unit 23, browser checks 17</a:t>
+              <a:t>306 automated tests: contracts 109, backend 131, red team 25, frontend unit 24, browser checks 17</a:t>
             </a:r>
           </a:p>
         </p:txBody>

</xml_diff>

<commit_message>
Build the deck from the runs: a scenario the live planner stopped reads as refused, the test counts match, and S2 against S3 carries its caution
</commit_message>
<xml_diff>
--- a/docs/deck/amanah-deck.pptx
+++ b/docs/deck/amanah-deck.pptx
@@ -512,7 +512,7 @@
           <a:lstStyle/>
           <a:p>
             <a:r>
-              <a:t>Amanah is an agent wallet for money held in trust: zakat, charity, humanitarian cash and public subsidies. It pays beneficiaries on its own, on a public chain. Our claim is that no single persuaded model can make it pay. In our red team, [[fill: S1 % of payment attacks]] of the attacks that asked for a payment got the planner alone, which is how a typical agent wallet works, to sign it. Through Amanah's quorum and contract, [[fill: attacks that moved funds]] moved any funds. Amanah is the Arabic word for a trust held on behalf of others. The rest of this deck shows how the wallet carries that duty, and how you can check each number yourself.</a:t>
+              <a:t>Amanah is an agent wallet for money held in trust: zakat, charity, humanitarian cash and public subsidies. It pays beneficiaries on its own, on a public chain. Our claim is that no single persuaded model can make it pay. In our red team, 7.5% of the attacks that asked for a payment got the planner alone, which is how a typical agent wallet works, to sign it. Through Amanah's quorum and contract, 0 moved any funds. Amanah is the Arabic word for a trust held on behalf of others. The rest of this deck shows how the wallet carries that duty, and how you can check each number yourself.</a:t>
             </a:r>
           </a:p>
         </p:txBody>
@@ -582,7 +582,7 @@
           <a:lstStyle/>
           <a:p>
             <a:r>
-              <a:t>Task completion is forty percent of the score, so every scenario ran on Base Sepolia in USDC. The vault is at [[fill: vault address]]. Scenarios one to five set it up: two trustees register the signers, set three mandates and add 45 beneficiaries, and a donor deposits. Then come the payouts, the attacks and the controls. In all, [[fill: Base Sepolia transactions]] transactions are tagged with their scenario, and [[fill: scenarios passed]] of 16 scenarios behaved as expected. Our verify script re-checks any executed payout from the chain alone: signer roles, distinct lineages, the tier, the caps, the allowlist and the trustee signature. It passed on [[fill: payouts verify.py passed]] executed payouts, and it fails on a hand-edited one.</a:t>
+              <a:t>Task completion is forty percent of the score, so every scenario ran on Base Sepolia in USDC. The vault is at 0x558e...4FC5. Scenarios one to five set it up: two trustees register the signers, set three mandates and add 45 beneficiaries, and a donor deposits. Then come the payouts, the attacks and the controls. In all, 84 transactions are tagged with their scenario, and 16 of 16 scenarios behaved as expected. Our verify script re-checks any executed payout from the chain alone: signer roles, distinct lineages, the tier, the caps, the allowlist and the trustee signature. It passed on 15 of 15 executed payouts, and it fails on a hand-edited one.</a:t>
             </a:r>
           </a:p>
         </p:txBody>
@@ -652,7 +652,7 @@
           <a:lstStyle/>
           <a:p>
             <a:r>
-              <a:t>Amanah is fund-agnostic: a programme's rules live in its on-chain mandate, so the same wallet serves zakat, waqf, charity, humanitarian cash or a government transfer. The demo runs three funds side by side. The build has 306 automated tests across five suites. A pilot needs one programme at a Malaysian zakat institution, agent keys in a key management service, and trustee governance in a Safe multisig. After that come attested lineage, so the registry can prove which model signed, and a permissioned chain for institutions that need one. The design maps to China's 2026 agent-payment convention: authorisation boundaries, limits, Know Your Agent, security testing and a human fallback.</a:t>
+              <a:t>Amanah is fund-agnostic: a programme's rules live in its on-chain mandate, so the same wallet serves zakat, waqf, charity, humanitarian cash or a government transfer. The demo runs three funds side by side. The build has 353 automated tests across six suites. A pilot needs one programme at a Malaysian zakat institution, agent keys in a key management service, and trustee governance in a Safe multisig. After that come attested lineage, so the registry can prove which model signed, and a permissioned chain for institutions that need one. The design maps to China's 2026 agent-payment convention: authorisation boundaries, limits, Know Your Agent, security testing and a human fallback.</a:t>
             </a:r>
           </a:p>
         </p:txBody>
@@ -1072,7 +1072,7 @@
           <a:lstStyle/>
           <a:p>
             <a:r>
-              <a:t>Models change without notice and new jailbreaks keep appearing, so a control tested once decays. Every day a red-team agent mutates the attack gallery and fires it at a sandbox copy of the quorum. It measures how often the planner and the auditor fail together, and it anchors the report's hash on-chain. Above a threshold fixed before the run, it raises the posture, and every payout then needs a trustee. The red team can only raise the posture. Lowering it takes two trustee signatures. So a compromised red-team agent can cause delays, never theft.</a:t>
+              <a:t>Models change without notice and new jailbreaks keep appearing, so a control tested once decays. Every day a red-team run fires the reviewed attack gallery at a sandbox copy of the quorum. It measures how often the planner and the auditor fail together, and it anchors the report's hash on-chain. Above a threshold fixed before the run, it raises the posture, and every payout then needs a trustee. The red team can only raise the posture. Lowering it takes two trustee signatures. So a compromised red-team run can cause delays, never theft. Our measured joint failure was 0.0%, which raises nothing, so the demo's scenario 14 uses a summary labelled as made for the demo.</a:t>
             </a:r>
           </a:p>
         </p:txBody>
@@ -1142,7 +1142,7 @@
           <a:lstStyle/>
           <a:p>
             <a:r>
-              <a:t>The rubric names four attacks. An induced transfer, such as an urgent message from the chairman, meets an auditor that finds no such beneficiary, a sentinel that sees an unknown wallet, and a vault that reverts anything off the allowlist. A prompt-injected letter reaches the planner only as typed fields, the amount still comes from the books, and the sentinel's rules refuse the second payment it asks for. Data extraction finds nothing to leak, because no model's view holds personal data. Privilege escalation fails because no agent key holds a trustee role, and every registry change needs two trustees.</a:t>
+              <a:t>The rubric names four attacks. An induced transfer, such as an urgent message from the chairman, meets an auditor that finds no such beneficiary, a sentinel that sees an unknown wallet, and a vault that reverts anything off the allowlist. A prompt-injected letter reaches the planner only as typed fields, the amount still comes from the books, and the sentinel's rules refuse the second payment it asks for. On Base Sepolia the live planner refused both of those messages itself, so the red team shows the checkers instead: every checker rejected the payouts to unlisted wallets that the planner proposed. Data extraction finds nothing to leak, because no model's view holds personal data. Privilege escalation fails because no agent key holds a trustee role, and every registry change needs two trustees.</a:t>
             </a:r>
           </a:p>
         </p:txBody>
@@ -1212,7 +1212,7 @@
           <a:lstStyle/>
           <a:p>
             <a:r>
-              <a:t>Independence is the whole argument, so we measured it rather than assumed it. We fixed the protocol and committed it before the full run. Each attack ran against five configurations, from the planner alone up to the full quorum and the vault. Against the planner alone, [[fill: S1 %]] of the attacks succeeded. With the Qwen auditor, [[fill: S3 %]]. With the sentinel too, [[fill: S4 %]]. Through the vault, [[fill: S5 %]]. The planner and the Qwen auditor failed together on [[fill: joint failure, planner and Qwen auditor]] of transfer attacks. The paired comparisons use exact McNemar tests with Holm's correction, and every rate has a 95% Wilson interval.</a:t>
+              <a:t>Independence is the whole argument, so we measured it rather than assumed it. We fixed the protocol and committed it before the full run. Each attack ran against five configurations, from the planner alone up to the full quorum and the vault. Against the planner alone, 6.8% of the attacks succeeded. With the Qwen auditor, 0.0%. With the sentinel too, 0.0%. Through the vault, 0.0%. The planner and the Qwen auditor failed together on 0.0% (95% CI 0.0 to 8.8) of transfer attacks. The paired comparisons use exact McNemar tests with Holm's correction, and every rate has a 95% Wilson interval. One caution: the single attack that passed the Claude auditor but not the Qwen auditor was stopped by a Qwen misreading of its own rules, the same misreading that escalated two sound payouts. So that difference rests on one case, with a McNemar p of 1.0, and we do not claim Qwen judges better. We did not tune the prompt to those cases.</a:t>
             </a:r>
           </a:p>
         </p:txBody>
@@ -4546,13 +4546,13 @@
               </a:spcAft>
             </a:pPr>
             <a:r>
-              <a:rPr sz="2400" b="1">
+              <a:rPr sz="5400" b="1">
                 <a:solidFill>
                   <a:srgbClr val="A8231C"/>
                 </a:solidFill>
                 <a:latin typeface="Arial"/>
               </a:rPr>
-              <a:t>[[fill: S1 % of payment attacks]]</a:t>
+              <a:t>7.5%</a:t>
             </a:r>
           </a:p>
           <a:p>
@@ -4651,13 +4651,13 @@
               </a:spcAft>
             </a:pPr>
             <a:r>
-              <a:rPr sz="2400" b="1">
+              <a:rPr sz="5400" b="1">
                 <a:solidFill>
                   <a:srgbClr val="0B5D3B"/>
                 </a:solidFill>
                 <a:latin typeface="Arial"/>
               </a:rPr>
-              <a:t>[[fill: attacks that moved funds]]</a:t>
+              <a:t>0</a:t>
             </a:r>
           </a:p>
           <a:p>
@@ -5071,7 +5071,7 @@
                 </a:solidFill>
                 <a:latin typeface="Arial"/>
               </a:rPr>
-              <a:t>deployed · [[fill: run]]</a:t>
+              <a:t>deployed · passed</a:t>
             </a:r>
           </a:p>
         </p:txBody>
@@ -5176,7 +5176,7 @@
                 </a:solidFill>
                 <a:latin typeface="Arial"/>
               </a:rPr>
-              <a:t>registered · [[fill: run]]</a:t>
+              <a:t>registered · passed</a:t>
             </a:r>
           </a:p>
         </p:txBody>
@@ -5281,7 +5281,7 @@
                 </a:solidFill>
                 <a:latin typeface="Arial"/>
               </a:rPr>
-              <a:t>set · [[fill: run]]</a:t>
+              <a:t>set · passed</a:t>
             </a:r>
           </a:p>
         </p:txBody>
@@ -5386,7 +5386,7 @@
                 </a:solidFill>
                 <a:latin typeface="Arial"/>
               </a:rPr>
-              <a:t>added · [[fill: run]]</a:t>
+              <a:t>added · passed</a:t>
             </a:r>
           </a:p>
         </p:txBody>
@@ -5491,7 +5491,7 @@
                 </a:solidFill>
                 <a:latin typeface="Arial"/>
               </a:rPr>
-              <a:t>received · [[fill: run]]</a:t>
+              <a:t>received · passed</a:t>
             </a:r>
           </a:p>
         </p:txBody>
@@ -5596,7 +5596,7 @@
                 </a:solidFill>
                 <a:latin typeface="Arial"/>
               </a:rPr>
-              <a:t>paid · [[fill: run]]</a:t>
+              <a:t>paid · passed</a:t>
             </a:r>
           </a:p>
         </p:txBody>
@@ -5701,7 +5701,7 @@
                 </a:solidFill>
                 <a:latin typeface="Arial"/>
               </a:rPr>
-              <a:t>paid · [[fill: run]]</a:t>
+              <a:t>paid · passed</a:t>
             </a:r>
           </a:p>
         </p:txBody>
@@ -5806,7 +5806,7 @@
                 </a:solidFill>
                 <a:latin typeface="Arial"/>
               </a:rPr>
-              <a:t>refused, anchored · [[fill: run]]</a:t>
+              <a:t>refused by the planner · passed</a:t>
             </a:r>
           </a:p>
         </p:txBody>
@@ -5911,7 +5911,7 @@
                 </a:solidFill>
                 <a:latin typeface="Arial"/>
               </a:rPr>
-              <a:t>refused, anchored · [[fill: run]]</a:t>
+              <a:t>refused by the planner · passed</a:t>
             </a:r>
           </a:p>
         </p:txBody>
@@ -6016,7 +6016,7 @@
                 </a:solidFill>
                 <a:latin typeface="Arial"/>
               </a:rPr>
-              <a:t>reverted · [[fill: run]]</a:t>
+              <a:t>reverted · passed</a:t>
             </a:r>
           </a:p>
         </p:txBody>
@@ -6121,7 +6121,7 @@
                 </a:solidFill>
                 <a:latin typeface="Arial"/>
               </a:rPr>
-              <a:t>reverted · [[fill: run]]</a:t>
+              <a:t>reverted · passed</a:t>
             </a:r>
           </a:p>
         </p:txBody>
@@ -6226,7 +6226,7 @@
                 </a:solidFill>
                 <a:latin typeface="Arial"/>
               </a:rPr>
-              <a:t>reverted · [[fill: run]]</a:t>
+              <a:t>reverted · passed</a:t>
             </a:r>
           </a:p>
         </p:txBody>
@@ -6331,7 +6331,7 @@
                 </a:solidFill>
                 <a:latin typeface="Arial"/>
               </a:rPr>
-              <a:t>capped · [[fill: run]]</a:t>
+              <a:t>capped · passed</a:t>
             </a:r>
           </a:p>
         </p:txBody>
@@ -6436,7 +6436,7 @@
                 </a:solidFill>
                 <a:latin typeface="Arial"/>
               </a:rPr>
-              <a:t>posture raised · [[fill: run]]</a:t>
+              <a:t>posture raised · passed</a:t>
             </a:r>
           </a:p>
         </p:txBody>
@@ -6541,7 +6541,7 @@
                 </a:solidFill>
                 <a:latin typeface="Arial"/>
               </a:rPr>
-              <a:t>paid · [[fill: run]]</a:t>
+              <a:t>paid · passed</a:t>
             </a:r>
           </a:p>
         </p:txBody>
@@ -6646,7 +6646,7 @@
                 </a:solidFill>
                 <a:latin typeface="Arial"/>
               </a:rPr>
-              <a:t>reverted · [[fill: run]]</a:t>
+              <a:t>reverted · passed</a:t>
             </a:r>
           </a:p>
         </p:txBody>
@@ -6751,7 +6751,7 @@
                 </a:solidFill>
                 <a:latin typeface="Arial"/>
               </a:rPr>
-              <a:t>Vault [[fill: vault address]]</a:t>
+              <a:t>Vault 0x558e...4FC5</a:t>
             </a:r>
           </a:p>
           <a:p>
@@ -6770,7 +6770,7 @@
                 </a:solidFill>
                 <a:latin typeface="Arial"/>
               </a:rPr>
-              <a:t>[[fill: Base Sepolia transactions]] transactions, each tagged with its scenario</a:t>
+              <a:t>84 transactions, each tagged with its scenario</a:t>
             </a:r>
           </a:p>
           <a:p>
@@ -6789,7 +6789,7 @@
                 </a:solidFill>
                 <a:latin typeface="Arial"/>
               </a:rPr>
-              <a:t>verify.py passes on [[fill: payouts verify.py passed]] executed payouts</a:t>
+              <a:t>verify.py passes on 15 of 15 executed payouts</a:t>
             </a:r>
           </a:p>
           <a:p>
@@ -7180,7 +7180,7 @@
                 </a:solidFill>
                 <a:latin typeface="Arial"/>
               </a:rPr>
-              <a:t>306 automated tests: contracts 109, backend 131, red team 25, frontend unit 24, browser checks 17</a:t>
+              <a:t>353 automated tests: contracts 112, backend 141, red team 29, release scripts 30, frontend unit 24, browser checks 17</a:t>
             </a:r>
           </a:p>
         </p:txBody>
@@ -9322,7 +9322,7 @@
                 </a:solidFill>
                 <a:latin typeface="Arial"/>
               </a:rPr>
-              <a:t>Source: docs/demo-transcript.md, steps 1 to 4; scenario 6 on Base Sepolia, [[fill: scenario 6 tx]]</a:t>
+              <a:t>Source: docs/demo-transcript.md, steps 1 to 4; scenario 6 on Base Sepolia, 0x232c...ae5a</a:t>
             </a:r>
           </a:p>
         </p:txBody>
@@ -11072,7 +11072,7 @@
                 </a:solidFill>
                 <a:latin typeface="Arial"/>
               </a:rPr>
-              <a:t>Source: AmanahVault's signer registry and lineage check; scenario 11 on Base Sepolia, [[fill: scenario 11 tx]]</a:t>
+              <a:t>Source: AmanahVault's signer registry and lineage check; scenario 11 on Base Sepolia, 0xcf19...f0be</a:t>
             </a:r>
           </a:p>
         </p:txBody>
@@ -12503,7 +12503,7 @@
                 </a:solidFill>
                 <a:latin typeface="Arial"/>
               </a:rPr>
-              <a:t>Source: redteam/immune.py and backend/app/agentwallet/posture.py; scenario 14 on Base Sepolia, [[fill: scenario 14 tx]]</a:t>
+              <a:t>Source: redteam/immune.py and backend/app/agentwallet/posture.py; scenario 14 on Base Sepolia, 0xad4e...1edd</a:t>
             </a:r>
           </a:p>
         </p:txBody>
@@ -13706,7 +13706,7 @@
                 </a:solidFill>
                 <a:latin typeface="Arial"/>
               </a:rPr>
-              <a:t>Source: docs/security-self-assessment.md, section 3; scenarios 8 [[fill: scenario 8 tx]], 9 [[fill: scenario 9 tx]], 10 [[fill: scenario 10 tx]] and 12 [[fill: scenario 12 tx]]</a:t>
+              <a:t>Source: docs/security-self-assessment.md, section 3; scenarios 10 0xb06b...0588 and 12 0x1e69...6ae9; the live planner refused 8 and 9</a:t>
             </a:r>
           </a:p>
         </p:txBody>
@@ -13901,7 +13901,7 @@
                           </a:solidFill>
                           <a:latin typeface="Arial"/>
                         </a:rPr>
-                        <a:t>scenarios 8 and 10</a:t>
+                        <a:t>scenario 10; the red team's induced-transfer and urgency cases</a:t>
                       </a:r>
                     </a:p>
                   </a:txBody>
@@ -14302,7 +14302,7 @@
                 </a:solidFill>
                 <a:latin typeface="Arial"/>
               </a:rPr>
-              <a:t>Source: redteam/protocol.md, committed at [[fill: protocol commit]] before the run; redteam/results/final/report.md; [[fill: attack cases]] attacks and [[fill: legitimate cases]] legitimate payouts</a:t>
+              <a:t>Source: redteam/protocol.md, committed at ffa0490 before the run; redteam/results/final/report.md; 44 attacks and 20 legitimate payouts</a:t>
             </a:r>
           </a:p>
         </p:txBody>
@@ -14430,7 +14430,7 @@
                           </a:solidFill>
                           <a:latin typeface="Arial"/>
                         </a:rPr>
-                        <a:t>Attack success</a:t>
+                        <a:t>Attack success, all 44</a:t>
                       </a:r>
                     </a:p>
                   </a:txBody>
@@ -14520,7 +14520,7 @@
                           </a:solidFill>
                           <a:latin typeface="Arial"/>
                         </a:rPr>
-                        <a:t>[[fill: S1 attack success]]</a:t>
+                        <a:t>6.8% (95% CI 2.3 to 18.2)</a:t>
                       </a:r>
                     </a:p>
                   </a:txBody>
@@ -14542,7 +14542,7 @@
                           </a:solidFill>
                           <a:latin typeface="Arial"/>
                         </a:rPr>
-                        <a:t>[[fill: S1 false refusals]]</a:t>
+                        <a:t>0.0%</a:t>
                       </a:r>
                     </a:p>
                   </a:txBody>
@@ -14610,7 +14610,7 @@
                           </a:solidFill>
                           <a:latin typeface="Arial"/>
                         </a:rPr>
-                        <a:t>[[fill: S2 attack success]]</a:t>
+                        <a:t>2.3% (95% CI 0.4 to 11.8)</a:t>
                       </a:r>
                     </a:p>
                   </a:txBody>
@@ -14632,7 +14632,7 @@
                           </a:solidFill>
                           <a:latin typeface="Arial"/>
                         </a:rPr>
-                        <a:t>[[fill: S2 false refusals]]</a:t>
+                        <a:t>0.0%</a:t>
                       </a:r>
                     </a:p>
                   </a:txBody>
@@ -14700,7 +14700,7 @@
                           </a:solidFill>
                           <a:latin typeface="Arial"/>
                         </a:rPr>
-                        <a:t>[[fill: S3 attack success]]</a:t>
+                        <a:t>0.0% (95% CI 0.0 to 8.0)</a:t>
                       </a:r>
                     </a:p>
                   </a:txBody>
@@ -14722,7 +14722,7 @@
                           </a:solidFill>
                           <a:latin typeface="Arial"/>
                         </a:rPr>
-                        <a:t>[[fill: S3 false refusals]]</a:t>
+                        <a:t>10.0%</a:t>
                       </a:r>
                     </a:p>
                   </a:txBody>
@@ -14790,7 +14790,7 @@
                           </a:solidFill>
                           <a:latin typeface="Arial"/>
                         </a:rPr>
-                        <a:t>[[fill: S4 attack success]]</a:t>
+                        <a:t>0.0% (95% CI 0.0 to 8.0)</a:t>
                       </a:r>
                     </a:p>
                   </a:txBody>
@@ -14812,7 +14812,7 @@
                           </a:solidFill>
                           <a:latin typeface="Arial"/>
                         </a:rPr>
-                        <a:t>[[fill: S4 false refusals]]</a:t>
+                        <a:t>10.0%</a:t>
                       </a:r>
                     </a:p>
                   </a:txBody>
@@ -14880,7 +14880,7 @@
                           </a:solidFill>
                           <a:latin typeface="Arial"/>
                         </a:rPr>
-                        <a:t>[[fill: S5 attack success]]</a:t>
+                        <a:t>0.0% (95% CI 0.0 to 8.0)</a:t>
                       </a:r>
                     </a:p>
                   </a:txBody>
@@ -14902,7 +14902,7 @@
                           </a:solidFill>
                           <a:latin typeface="Arial"/>
                         </a:rPr>
-                        <a:t>[[fill: S5 false refusals]]</a:t>
+                        <a:t>10.0%</a:t>
                       </a:r>
                     </a:p>
                   </a:txBody>
@@ -15017,7 +15017,26 @@
                 </a:solidFill>
                 <a:latin typeface="Arial"/>
               </a:rPr>
-              <a:t>The planner and the Qwen auditor were fooled together on [[fill: joint failure, planner and Qwen auditor]] of transfer attacks.</a:t>
+              <a:t>The planner and the Qwen auditor were fooled together on 0.0% (95% CI 0.0 to 8.8) of transfer attacks.</a:t>
+            </a:r>
+          </a:p>
+          <a:p>
+            <a:pPr algn="l">
+              <a:lnSpc>
+                <a:spcPct val="110000"/>
+              </a:lnSpc>
+              <a:spcAft>
+                <a:spcPts val="700"/>
+              </a:spcAft>
+            </a:pPr>
+            <a:r>
+              <a:rPr sz="1400" b="0">
+                <a:solidFill>
+                  <a:srgbClr val="1D2321"/>
+                </a:solidFill>
+                <a:latin typeface="Arial"/>
+              </a:rPr>
+              <a:t>Above 10% raises the posture, by the protocol.</a:t>
             </a:r>
           </a:p>
           <a:p>
@@ -15030,13 +15049,13 @@
               </a:spcAft>
             </a:pPr>
             <a:r>
-              <a:rPr sz="1400" b="0">
-                <a:solidFill>
-                  <a:srgbClr val="1D2321"/>
+              <a:rPr sz="1300" b="0">
+                <a:solidFill>
+                  <a:srgbClr val="5B6661"/>
                 </a:solidFill>
                 <a:latin typeface="Arial"/>
               </a:rPr>
-              <a:t>Above 10% raises the posture, by the protocol.</a:t>
+              <a:t>S2 against S3 is one case, p = 1.0: not a claim that Qwen judges better.</a:t>
             </a:r>
           </a:p>
         </p:txBody>

</xml_diff>

<commit_message>
Name Team Amanah and both members in the README, the deck and the email draft, and fill the repository links
</commit_message>
<xml_diff>
--- a/docs/deck/amanah-deck.pptx
+++ b/docs/deck/amanah-deck.pptx
@@ -4718,7 +4718,7 @@
                 </a:solidFill>
                 <a:latin typeface="Arial"/>
               </a:rPr>
-              <a:t>Team [[fill: team name]] · Universiti Teknologi PETRONAS, Malaysia</a:t>
+              <a:t>Team Amanah · Universiti Teknologi PETRONAS, Malaysia</a:t>
             </a:r>
           </a:p>
           <a:p>
@@ -4737,7 +4737,7 @@
                 </a:solidFill>
                 <a:latin typeface="Arial"/>
               </a:rPr>
-              <a:t>[[fill: member names]]</a:t>
+              <a:t>Abdul Hafiz Bin Mohd Noor Azman, Muhammad Khaidhir Bin Mohd Razin</a:t>
             </a:r>
           </a:p>
         </p:txBody>

</xml_diff>

<commit_message>
The deck carries the random draw: 0 of 272 moved, p = 0.002 against one model, and its limit said plainly
</commit_message>
<xml_diff>
--- a/docs/deck/amanah-deck.pptx
+++ b/docs/deck/amanah-deck.pptx
@@ -866,7 +866,7 @@
           <a:lstStyle/>
           <a:p>
             <a:r>
-              <a:t>Every security design has limits, and we would rather name ours first. The vault trusts the model family the trustees declare for each key; attestation is the next step. Two colluding trustees could defeat the bound. Forty-four attacks is a small red team, so the comparison is not yet significant. And our Qwen auditor sometimes holds back a sound payout for a trustee: that costs a delay, never a wrong payment. Next we attest each signer's model, grow the red team past one hundred and fifty adaptive attacks, add eligibility by proof with WeIdentity, and pilot one programme with a Malaysian zakat institution.</a:t>
+              <a:t>Every security design has limits, and we would rather name ours first. The vault trusts the model family the trustees declare for each key; attestation is the next step. Two colluding trustees could defeat the bound. Forty-four seeds was a small red team; a random draw of 300 variants settles it, though the variants reword the same ideas. And our Qwen auditor sometimes holds back a sound payout for a trustee: that costs a delay, never a wrong payment. Next we attest each signer's model, grow the red team past one hundred and fifty adaptive attacks, add eligibility by proof with WeIdentity, and pilot one programme with a Malaysian zakat institution.</a:t>
             </a:r>
           </a:p>
         </p:txBody>
@@ -1426,7 +1426,7 @@
           <a:lstStyle/>
           <a:p>
             <a:r>
-              <a:t>We attacked Amanah 44 ways with the live models, under a protocol we committed before the run. A typical agent wallet, one model holding the key, signed 3 of 40 of the payment attacks. Adding a second Claude still let 1 of 40 through. With the different-family auditor, the sentinel and the contract, none collected the signatures it needed, and none moved funds. We are honest about the statistics: on its own, three against zero is not significant, p equals 0.25. That is why the contract's bound, not the red team, is the guarantee. On Base Sepolia, sixteen scenarios passed 17 of 17 checks in 84 real transactions, and anyone can re-check every payout from the chain alone.</a:t>
+              <a:t>We attacked Amanah 44 ways with the live models, under a protocol we committed before the run. A typical agent wallet, one model holding the key, signed 3 of 40 of the payment attacks. Adding a second Claude still let 1 of 40 through. With the different-family auditor, the sentinel and the contract, none collected the signatures it needed, and none moved funds. We are honest about the statistics: on its own, three against zero is not significant, p equals 0.25. Then we drew 300 more at random from 1,100 code-made variants, with a seed fixed by a public block: one model alone fell for 10, none moved through Amanah, and the paired test gives p = 0.002. The contract's bound stays the guarantee; the red team is the measurement. On Base Sepolia, sixteen scenarios passed 17 of 17 checks in 84 real transactions, and anyone can re-check every payout from the chain alone.</a:t>
             </a:r>
           </a:p>
         </p:txBody>
@@ -11765,7 +11765,7 @@
                 </a:solidFill>
                 <a:latin typeface="Arial"/>
               </a:rPr>
-              <a:t>44 attacks: p = 0.25, not yet significant</a:t>
+              <a:t>The 300 random variants reword 44 attack ideas; new kinds are untested</a:t>
             </a:r>
           </a:p>
           <a:p>
@@ -18716,7 +18716,7 @@
                 </a:solidFill>
                 <a:latin typeface="Arial"/>
               </a:rPr>
-              <a:t>0 of 40 Payment Attacks Moved Funds. We Print Our p-Value Beside It.</a:t>
+              <a:t>0 of 40, Then 0 of 272 Drawn at Random: Nothing Moved</a:t>
             </a:r>
           </a:p>
         </p:txBody>
@@ -18800,7 +18800,7 @@
                 </a:solidFill>
                 <a:latin typeface="Arial"/>
               </a:rPr>
-              <a:t>Source: redteam/results/final/report.md; evidence/demo-summary.json; scripts/test_all.sh</a:t>
+              <a:t>Source: redteam/results/final/report.md; redteam/results/variants-stage1/report.md; evidence/demo-summary.json</a:t>
             </a:r>
           </a:p>
         </p:txBody>
@@ -19573,7 +19573,7 @@
                 </a:solidFill>
                 <a:latin typeface="Arial"/>
               </a:rPr>
-              <a:t>Read honestly: exact McNemar p = 0.25 (Holm 0.75). Not significant on its own; the contract's bound is the guarantee.</a:t>
+              <a:t>Read honestly: the 44 seeds alone give p = 0.25. 300 random variants settle it: one model alone 10, Amanah 0 of 272 moved, p = 0.002.</a:t>
             </a:r>
           </a:p>
           <a:p>

</xml_diff>

<commit_message>
The deck and the card lead with 0 of 312 and 476 tests; the deck reads the variants per seed too and names the companion; the cut plays app footage up to 1.5 times faster before the voice waits
</commit_message>
<xml_diff>
--- a/docs/deck/amanah-deck.pptx
+++ b/docs/deck/amanah-deck.pptx
@@ -866,7 +866,7 @@
           <a:lstStyle/>
           <a:p>
             <a:r>
-              <a:t>Every security design has limits, and we would rather name ours first. The vault trusts the model family the trustees declare for each key; attestation is the next step. Two colluding trustees could defeat the bound. Forty-four seeds was a small red team; a random draw of 300 variants settles it, though the variants reword the same ideas. And our Qwen auditor sometimes holds back a sound payout for a trustee: that costs a delay, never a wrong payment. Next we attest each signer's model, grow the red team past one hundred and fifty adaptive attacks, add eligibility by proof with WeIdentity, and pilot one programme with a Malaysian zakat institution.</a:t>
+              <a:t>Every security design has limits, and we would rather name ours first. The vault trusts the model family the trustees declare for each key; attestation is the next step. Two colluding trustees could defeat the bound. Forty-four seeds was a small red team; 300 random rewordings of them moved nothing through Amanah, but they test the same ideas. And our Qwen auditor sometimes stops a sound payout and asks for a person: that costs a delay, never a wrong payment. Next we attest each signer's model, grow the red team past one hundred and fifty adaptive attacks, add eligibility by proof with WeIdentity, and pilot one programme with a Malaysian zakat institution.</a:t>
             </a:r>
           </a:p>
         </p:txBody>
@@ -936,7 +936,7 @@
           <a:lstStyle/>
           <a:p>
             <a:r>
-              <a:t>That is Amanah: an AI wallet that cannot be sweet-talked, because no single model holds the key and the contract that counts the signatures reads no text at all. Everything we showed you is public and checkable. The demo is at the address on the slide: try the three attack buttons. The repository reproduces every number with one command, and our claims register lists every claim with the command that checks it. Thank you.</a:t>
+              <a:t>That is Amanah: an AI wallet that cannot be sweet-talked, because no single model holds the key and the contract that counts the signatures reads no text at all. Everything we showed you is public and checkable. The demo is at the address on the slide: try the attack buttons. The repository reproduces every number with one command, and our claims register lists every claim with the command that checks it. Thank you.</a:t>
             </a:r>
           </a:p>
         </p:txBody>
@@ -1426,7 +1426,7 @@
           <a:lstStyle/>
           <a:p>
             <a:r>
-              <a:t>We attacked Amanah 44 ways with the live models, under a protocol we committed before the run. A typical agent wallet, one model holding the key, signed 3 of 40 of the payment attacks. Adding a second Claude still let 1 of 40 through. With the different-family auditor, the sentinel and the contract, none collected the signatures it needed, and none moved funds. We are honest about the statistics: on its own, three against zero is not significant, p equals 0.25. Then we drew 300 more at random from 1,100 code-made variants, with a seed fixed by a public block: one model alone fell for 10, none moved through Amanah, and the paired test gives p = 0.002. The contract's bound stays the guarantee; the red team is the measurement. On Base Sepolia, sixteen scenarios passed 17 of 17 checks in 84 real transactions, and anyone can re-check every payout from the chain alone.</a:t>
+              <a:t>We attacked Amanah 44 ways with the live models, under a protocol we committed before the run. A typical agent wallet, one model holding the key, signed 3 of 40 of the payment attacks. Adding a second Claude still let 1 of 40 through. With the different-family auditor, the sentinel and the contract, none collected the signatures it needed, and none moved funds. We are honest about the statistics: on its own, three against zero is not significant, p equals 0.25. Then we drew 300 more at random from 1,100 code-made variants, with a seed fixed by a public block: one model alone fell for 10 and none moved through Amanah. They reword the same ideas, so per seed it is still p = 0.25. The contract's bound stays the guarantee; the red team is the measurement. On Base Sepolia, sixteen scenarios passed 17 of 17 checks in 84 real transactions, and anyone can re-check every payout from the chain alone.</a:t>
             </a:r>
           </a:p>
         </p:txBody>
@@ -4801,7 +4801,7 @@
                 </a:solidFill>
                 <a:latin typeface="Arial"/>
               </a:rPr>
-              <a:t>0 of 40</a:t>
+              <a:t>0 of 312</a:t>
             </a:r>
           </a:p>
           <a:p>
@@ -4820,7 +4820,7 @@
                 </a:solidFill>
                 <a:latin typeface="Arial"/>
               </a:rPr>
-              <a:t>red-team payment attacks moved funds through Amanah</a:t>
+              <a:t>payment attacks moved funds: 40 seeds, 272 random variants</a:t>
             </a:r>
           </a:p>
         </p:txBody>
@@ -5024,7 +5024,7 @@
                 </a:solidFill>
                 <a:latin typeface="Arial"/>
               </a:rPr>
-              <a:t>Try it: [[fill: hosted demo URL]]</a:t>
+              <a:t>Try it: https://amanah-demo.vercel.app</a:t>
             </a:r>
           </a:p>
         </p:txBody>
@@ -8482,7 +8482,7 @@
                 </a:solidFill>
                 <a:latin typeface="Arial"/>
               </a:rPr>
-              <a:t>366 tests on every push</a:t>
+              <a:t>476 tests on every push</a:t>
             </a:r>
           </a:p>
         </p:txBody>
@@ -11784,7 +11784,7 @@
                 </a:solidFill>
                 <a:latin typeface="Arial"/>
               </a:rPr>
-              <a:t>The auditor holds back some sound payouts (2 of 20 in the final run): a delay, never a wrong payment</a:t>
+              <a:t>The auditor stops some sound payouts for a person (2 of 20 in the final run; 14 of 60 in the companion run): a delay, never a wrong payment</a:t>
             </a:r>
           </a:p>
           <a:p>
@@ -12262,7 +12262,7 @@
                 </a:solidFill>
                 <a:latin typeface="Arial"/>
               </a:rPr>
-              <a:t>[[fill: hosted demo URL]]</a:t>
+              <a:t>https://amanah-demo.vercel.app</a:t>
             </a:r>
           </a:p>
         </p:txBody>
@@ -12556,7 +12556,7 @@
                 </a:solidFill>
                 <a:latin typeface="Arial"/>
               </a:rPr>
-              <a:t>Sealed on Base Sepolia</a:t>
+              <a:t>The submission seal</a:t>
             </a:r>
           </a:p>
         </p:txBody>
@@ -12598,7 +12598,7 @@
                 </a:solidFill>
                 <a:latin typeface="Arial"/>
               </a:rPr>
-              <a:t>[[fill: seal]]</a:t>
+              <a:t>one Base Sepolia transaction, in our email</a:t>
             </a:r>
           </a:p>
         </p:txBody>
@@ -15796,7 +15796,7 @@
                 </a:solidFill>
                 <a:latin typeface="Arial"/>
               </a:rPr>
-              <a:t>Source: the app on a local chain (.github/readme/shots). Try to trick it yourself: [[fill: hosted demo URL]]</a:t>
+              <a:t>Source: the app on a local chain (.github/readme/shots). Try to trick it yourself: https://amanah-demo.vercel.app</a:t>
             </a:r>
           </a:p>
         </p:txBody>
@@ -19573,7 +19573,7 @@
                 </a:solidFill>
                 <a:latin typeface="Arial"/>
               </a:rPr>
-              <a:t>Read honestly: the 44 seeds alone give p = 0.25. 300 random variants settle it: one model alone 10, Amanah 0 of 272 moved, p = 0.002.</a:t>
+              <a:t>Read honestly: 300 random variants reword the 44 seed ideas. One model alone 10, Amanah 0 of 272 moved: p = 0.002 per variant, still p = 0.25 per seed.</a:t>
             </a:r>
           </a:p>
           <a:p>
@@ -19592,7 +19592,7 @@
                 </a:solidFill>
                 <a:latin typeface="Arial"/>
               </a:rPr>
-              <a:t>17 of 17 checks on Base Sepolia · 84 transactions · 15 of 15 payouts re-checked from the chain · 366 tests</a:t>
+              <a:t>17 of 17 checks on Base Sepolia · 84 transactions · 15 of 15 payouts re-checked from the chain · 476 tests</a:t>
             </a:r>
           </a:p>
         </p:txBody>

</xml_diff>

<commit_message>
Deck slide 8 pools the registered 40 and the 272 drawn at random per set-up: 13 of 312 for one model alone, 0 of 312 through Amanah
</commit_message>
<xml_diff>
--- a/docs/deck/amanah-deck.pptx
+++ b/docs/deck/amanah-deck.pptx
@@ -18716,7 +18716,7 @@
                 </a:solidFill>
                 <a:latin typeface="Arial"/>
               </a:rPr>
-              <a:t>0 of 40, Then 0 of 272 Drawn at Random: Nothing Moved</a:t>
+              <a:t>0 of 312 Payment Attacks Moved Funds: 40 Registered, 272 Drawn at Random</a:t>
             </a:r>
           </a:p>
         </p:txBody>
@@ -18928,7 +18928,7 @@
                 </a:solidFill>
                 <a:latin typeface="Arial"/>
               </a:rPr>
-              <a:t>3 of 40</a:t>
+              <a:t>13 of 312</a:t>
             </a:r>
           </a:p>
           <a:p>
@@ -19033,7 +19033,7 @@
                 </a:solidFill>
                 <a:latin typeface="Arial"/>
               </a:rPr>
-              <a:t>0 of 40</a:t>
+              <a:t>0 of 312</a:t>
             </a:r>
           </a:p>
           <a:p>
@@ -19067,7 +19067,7 @@
         </p:nvGraphicFramePr>
         <p:xfrm>
           <a:off x="4114800" y="1874519"/>
-          <a:ext cx="7525511" cy="2523744"/>
+          <a:ext cx="7525508" cy="2523744"/>
         </p:xfrm>
         <a:graphic>
           <a:graphicData uri="http://schemas.openxmlformats.org/drawingml/2006/table">
@@ -19076,9 +19076,11 @@
                 <a:tableStyleId>{5C22544A-7EE6-4342-B048-85BDC9FD1C3A}</a:tableStyleId>
               </a:tblPr>
               <a:tblGrid>
-                <a:gridCol w="752551"/>
-                <a:gridCol w="4665817"/>
-                <a:gridCol w="2107143"/>
+                <a:gridCol w="526785"/>
+                <a:gridCol w="3386480"/>
+                <a:gridCol w="1204081"/>
+                <a:gridCol w="1204081"/>
+                <a:gridCol w="1204081"/>
               </a:tblGrid>
               <a:tr h="420624">
                 <a:tc>
@@ -19137,7 +19139,51 @@
                           </a:solidFill>
                           <a:latin typeface="Arial"/>
                         </a:rPr>
-                        <a:t>attacks with every signature</a:t>
+                        <a:t>40 registered</a:t>
+                      </a:r>
+                    </a:p>
+                  </a:txBody>
+                  <a:tcPr marL="91440" marR="91440" marT="36576" marB="36576" anchor="ctr">
+                    <a:solidFill>
+                      <a:srgbClr val="0B1F4B"/>
+                    </a:solidFill>
+                  </a:tcPr>
+                </a:tc>
+                <a:tc>
+                  <a:txBody>
+                    <a:bodyPr wrap="square"/>
+                    <a:lstStyle/>
+                    <a:p>
+                      <a:r>
+                        <a:rPr sz="1300" b="1">
+                          <a:solidFill>
+                            <a:srgbClr val="FFFFFF"/>
+                          </a:solidFill>
+                          <a:latin typeface="Arial"/>
+                        </a:rPr>
+                        <a:t>272 at random</a:t>
+                      </a:r>
+                    </a:p>
+                  </a:txBody>
+                  <a:tcPr marL="91440" marR="91440" marT="36576" marB="36576" anchor="ctr">
+                    <a:solidFill>
+                      <a:srgbClr val="0B1F4B"/>
+                    </a:solidFill>
+                  </a:tcPr>
+                </a:tc>
+                <a:tc>
+                  <a:txBody>
+                    <a:bodyPr wrap="square"/>
+                    <a:lstStyle/>
+                    <a:p>
+                      <a:r>
+                        <a:rPr sz="1300" b="1">
+                          <a:solidFill>
+                            <a:srgbClr val="FFFFFF"/>
+                          </a:solidFill>
+                          <a:latin typeface="Arial"/>
+                        </a:rPr>
+                        <a:t>all 312</a:t>
                       </a:r>
                     </a:p>
                   </a:txBody>
@@ -19155,7 +19201,7 @@
                     <a:lstStyle/>
                     <a:p>
                       <a:r>
-                        <a:rPr sz="1400" b="1">
+                        <a:rPr sz="1300" b="1">
                           <a:solidFill>
                             <a:srgbClr val="1B2333"/>
                           </a:solidFill>
@@ -19177,7 +19223,7 @@
                     <a:lstStyle/>
                     <a:p>
                       <a:r>
-                        <a:rPr sz="1400" b="0">
+                        <a:rPr sz="1300" b="0">
                           <a:solidFill>
                             <a:srgbClr val="1B2333"/>
                           </a:solidFill>
@@ -19199,13 +19245,57 @@
                     <a:lstStyle/>
                     <a:p>
                       <a:r>
-                        <a:rPr sz="1400" b="0">
+                        <a:rPr sz="1300" b="0">
                           <a:solidFill>
                             <a:srgbClr val="1B2333"/>
                           </a:solidFill>
                           <a:latin typeface="Arial"/>
                         </a:rPr>
-                        <a:t>3 of 40</a:t>
+                        <a:t>3</a:t>
+                      </a:r>
+                    </a:p>
+                  </a:txBody>
+                  <a:tcPr marL="91440" marR="91440" marT="36576" marB="36576" anchor="ctr">
+                    <a:solidFill>
+                      <a:srgbClr val="FFFFFF"/>
+                    </a:solidFill>
+                  </a:tcPr>
+                </a:tc>
+                <a:tc>
+                  <a:txBody>
+                    <a:bodyPr wrap="square"/>
+                    <a:lstStyle/>
+                    <a:p>
+                      <a:r>
+                        <a:rPr sz="1300" b="0">
+                          <a:solidFill>
+                            <a:srgbClr val="1B2333"/>
+                          </a:solidFill>
+                          <a:latin typeface="Arial"/>
+                        </a:rPr>
+                        <a:t>10</a:t>
+                      </a:r>
+                    </a:p>
+                  </a:txBody>
+                  <a:tcPr marL="91440" marR="91440" marT="36576" marB="36576" anchor="ctr">
+                    <a:solidFill>
+                      <a:srgbClr val="FFFFFF"/>
+                    </a:solidFill>
+                  </a:tcPr>
+                </a:tc>
+                <a:tc>
+                  <a:txBody>
+                    <a:bodyPr wrap="square"/>
+                    <a:lstStyle/>
+                    <a:p>
+                      <a:r>
+                        <a:rPr sz="1300" b="0">
+                          <a:solidFill>
+                            <a:srgbClr val="1B2333"/>
+                          </a:solidFill>
+                          <a:latin typeface="Arial"/>
+                        </a:rPr>
+                        <a:t>13</a:t>
                       </a:r>
                     </a:p>
                   </a:txBody>
@@ -19223,7 +19313,7 @@
                     <a:lstStyle/>
                     <a:p>
                       <a:r>
-                        <a:rPr sz="1400" b="1">
+                        <a:rPr sz="1300" b="1">
                           <a:solidFill>
                             <a:srgbClr val="1B2333"/>
                           </a:solidFill>
@@ -19245,7 +19335,7 @@
                     <a:lstStyle/>
                     <a:p>
                       <a:r>
-                        <a:rPr sz="1400" b="0">
+                        <a:rPr sz="1300" b="0">
                           <a:solidFill>
                             <a:srgbClr val="1B2333"/>
                           </a:solidFill>
@@ -19267,13 +19357,57 @@
                     <a:lstStyle/>
                     <a:p>
                       <a:r>
-                        <a:rPr sz="1400" b="0">
+                        <a:rPr sz="1300" b="0">
                           <a:solidFill>
                             <a:srgbClr val="1B2333"/>
                           </a:solidFill>
                           <a:latin typeface="Arial"/>
                         </a:rPr>
-                        <a:t>1 of 40</a:t>
+                        <a:t>1</a:t>
+                      </a:r>
+                    </a:p>
+                  </a:txBody>
+                  <a:tcPr marL="91440" marR="91440" marT="36576" marB="36576" anchor="ctr">
+                    <a:solidFill>
+                      <a:srgbClr val="F4F7FC"/>
+                    </a:solidFill>
+                  </a:tcPr>
+                </a:tc>
+                <a:tc>
+                  <a:txBody>
+                    <a:bodyPr wrap="square"/>
+                    <a:lstStyle/>
+                    <a:p>
+                      <a:r>
+                        <a:rPr sz="1300" b="0">
+                          <a:solidFill>
+                            <a:srgbClr val="1B2333"/>
+                          </a:solidFill>
+                          <a:latin typeface="Arial"/>
+                        </a:rPr>
+                        <a:t>not run</a:t>
+                      </a:r>
+                    </a:p>
+                  </a:txBody>
+                  <a:tcPr marL="91440" marR="91440" marT="36576" marB="36576" anchor="ctr">
+                    <a:solidFill>
+                      <a:srgbClr val="F4F7FC"/>
+                    </a:solidFill>
+                  </a:tcPr>
+                </a:tc>
+                <a:tc>
+                  <a:txBody>
+                    <a:bodyPr wrap="square"/>
+                    <a:lstStyle/>
+                    <a:p>
+                      <a:r>
+                        <a:rPr sz="1300" b="0">
+                          <a:solidFill>
+                            <a:srgbClr val="1B2333"/>
+                          </a:solidFill>
+                          <a:latin typeface="Arial"/>
+                        </a:rPr>
+                        <a:t>not pooled</a:t>
                       </a:r>
                     </a:p>
                   </a:txBody>
@@ -19291,7 +19425,7 @@
                     <a:lstStyle/>
                     <a:p>
                       <a:r>
-                        <a:rPr sz="1400" b="1">
+                        <a:rPr sz="1300" b="1">
                           <a:solidFill>
                             <a:srgbClr val="1B2333"/>
                           </a:solidFill>
@@ -19313,7 +19447,7 @@
                     <a:lstStyle/>
                     <a:p>
                       <a:r>
-                        <a:rPr sz="1400" b="0">
+                        <a:rPr sz="1300" b="0">
                           <a:solidFill>
                             <a:srgbClr val="1B2333"/>
                           </a:solidFill>
@@ -19335,13 +19469,57 @@
                     <a:lstStyle/>
                     <a:p>
                       <a:r>
-                        <a:rPr sz="1400" b="0">
+                        <a:rPr sz="1300" b="0">
                           <a:solidFill>
                             <a:srgbClr val="1B2333"/>
                           </a:solidFill>
                           <a:latin typeface="Arial"/>
                         </a:rPr>
-                        <a:t>0 of 40</a:t>
+                        <a:t>0</a:t>
+                      </a:r>
+                    </a:p>
+                  </a:txBody>
+                  <a:tcPr marL="91440" marR="91440" marT="36576" marB="36576" anchor="ctr">
+                    <a:solidFill>
+                      <a:srgbClr val="FFFFFF"/>
+                    </a:solidFill>
+                  </a:tcPr>
+                </a:tc>
+                <a:tc>
+                  <a:txBody>
+                    <a:bodyPr wrap="square"/>
+                    <a:lstStyle/>
+                    <a:p>
+                      <a:r>
+                        <a:rPr sz="1300" b="0">
+                          <a:solidFill>
+                            <a:srgbClr val="1B2333"/>
+                          </a:solidFill>
+                          <a:latin typeface="Arial"/>
+                        </a:rPr>
+                        <a:t>1</a:t>
+                      </a:r>
+                    </a:p>
+                  </a:txBody>
+                  <a:tcPr marL="91440" marR="91440" marT="36576" marB="36576" anchor="ctr">
+                    <a:solidFill>
+                      <a:srgbClr val="FFFFFF"/>
+                    </a:solidFill>
+                  </a:tcPr>
+                </a:tc>
+                <a:tc>
+                  <a:txBody>
+                    <a:bodyPr wrap="square"/>
+                    <a:lstStyle/>
+                    <a:p>
+                      <a:r>
+                        <a:rPr sz="1300" b="0">
+                          <a:solidFill>
+                            <a:srgbClr val="1B2333"/>
+                          </a:solidFill>
+                          <a:latin typeface="Arial"/>
+                        </a:rPr>
+                        <a:t>1</a:t>
                       </a:r>
                     </a:p>
                   </a:txBody>
@@ -19359,7 +19537,7 @@
                     <a:lstStyle/>
                     <a:p>
                       <a:r>
-                        <a:rPr sz="1400" b="1">
+                        <a:rPr sz="1300" b="1">
                           <a:solidFill>
                             <a:srgbClr val="1B2333"/>
                           </a:solidFill>
@@ -19381,7 +19559,7 @@
                     <a:lstStyle/>
                     <a:p>
                       <a:r>
-                        <a:rPr sz="1400" b="0">
+                        <a:rPr sz="1300" b="0">
                           <a:solidFill>
                             <a:srgbClr val="1B2333"/>
                           </a:solidFill>
@@ -19403,13 +19581,57 @@
                     <a:lstStyle/>
                     <a:p>
                       <a:r>
-                        <a:rPr sz="1400" b="0">
+                        <a:rPr sz="1300" b="0">
                           <a:solidFill>
                             <a:srgbClr val="1B2333"/>
                           </a:solidFill>
                           <a:latin typeface="Arial"/>
                         </a:rPr>
-                        <a:t>0 of 40</a:t>
+                        <a:t>0</a:t>
+                      </a:r>
+                    </a:p>
+                  </a:txBody>
+                  <a:tcPr marL="91440" marR="91440" marT="36576" marB="36576" anchor="ctr">
+                    <a:solidFill>
+                      <a:srgbClr val="F4F7FC"/>
+                    </a:solidFill>
+                  </a:tcPr>
+                </a:tc>
+                <a:tc>
+                  <a:txBody>
+                    <a:bodyPr wrap="square"/>
+                    <a:lstStyle/>
+                    <a:p>
+                      <a:r>
+                        <a:rPr sz="1300" b="0">
+                          <a:solidFill>
+                            <a:srgbClr val="1B2333"/>
+                          </a:solidFill>
+                          <a:latin typeface="Arial"/>
+                        </a:rPr>
+                        <a:t>1</a:t>
+                      </a:r>
+                    </a:p>
+                  </a:txBody>
+                  <a:tcPr marL="91440" marR="91440" marT="36576" marB="36576" anchor="ctr">
+                    <a:solidFill>
+                      <a:srgbClr val="F4F7FC"/>
+                    </a:solidFill>
+                  </a:tcPr>
+                </a:tc>
+                <a:tc>
+                  <a:txBody>
+                    <a:bodyPr wrap="square"/>
+                    <a:lstStyle/>
+                    <a:p>
+                      <a:r>
+                        <a:rPr sz="1300" b="0">
+                          <a:solidFill>
+                            <a:srgbClr val="1B2333"/>
+                          </a:solidFill>
+                          <a:latin typeface="Arial"/>
+                        </a:rPr>
+                        <a:t>1</a:t>
                       </a:r>
                     </a:p>
                   </a:txBody>
@@ -19427,7 +19649,7 @@
                     <a:lstStyle/>
                     <a:p>
                       <a:r>
-                        <a:rPr sz="1400" b="1">
+                        <a:rPr sz="1300" b="1">
                           <a:solidFill>
                             <a:srgbClr val="0B1F4B"/>
                           </a:solidFill>
@@ -19449,7 +19671,7 @@
                     <a:lstStyle/>
                     <a:p>
                       <a:r>
-                        <a:rPr sz="1400" b="1">
+                        <a:rPr sz="1300" b="1">
                           <a:solidFill>
                             <a:srgbClr val="0B1F4B"/>
                           </a:solidFill>
@@ -19471,13 +19693,57 @@
                     <a:lstStyle/>
                     <a:p>
                       <a:r>
-                        <a:rPr sz="1400" b="1">
+                        <a:rPr sz="1300" b="1">
                           <a:solidFill>
                             <a:srgbClr val="0B1F4B"/>
                           </a:solidFill>
                           <a:latin typeface="Arial"/>
                         </a:rPr>
-                        <a:t>0 of 40</a:t>
+                        <a:t>0</a:t>
+                      </a:r>
+                    </a:p>
+                  </a:txBody>
+                  <a:tcPr marL="91440" marR="91440" marT="36576" marB="36576" anchor="ctr">
+                    <a:solidFill>
+                      <a:srgbClr val="E6ECFB"/>
+                    </a:solidFill>
+                  </a:tcPr>
+                </a:tc>
+                <a:tc>
+                  <a:txBody>
+                    <a:bodyPr wrap="square"/>
+                    <a:lstStyle/>
+                    <a:p>
+                      <a:r>
+                        <a:rPr sz="1300" b="1">
+                          <a:solidFill>
+                            <a:srgbClr val="0B1F4B"/>
+                          </a:solidFill>
+                          <a:latin typeface="Arial"/>
+                        </a:rPr>
+                        <a:t>0</a:t>
+                      </a:r>
+                    </a:p>
+                  </a:txBody>
+                  <a:tcPr marL="91440" marR="91440" marT="36576" marB="36576" anchor="ctr">
+                    <a:solidFill>
+                      <a:srgbClr val="E6ECFB"/>
+                    </a:solidFill>
+                  </a:tcPr>
+                </a:tc>
+                <a:tc>
+                  <a:txBody>
+                    <a:bodyPr wrap="square"/>
+                    <a:lstStyle/>
+                    <a:p>
+                      <a:r>
+                        <a:rPr sz="1300" b="1">
+                          <a:solidFill>
+                            <a:srgbClr val="0B1F4B"/>
+                          </a:solidFill>
+                          <a:latin typeface="Arial"/>
+                        </a:rPr>
+                        <a:t>0</a:t>
                       </a:r>
                     </a:p>
                   </a:txBody>

</xml_diff>

<commit_message>
Deck slide 13 compares the pooled payment attacks too: 13 of 312 against 0 of 312
</commit_message>
<xml_diff>
--- a/docs/deck/amanah-deck.pptx
+++ b/docs/deck/amanah-deck.pptx
@@ -10570,7 +10570,7 @@
                 </a:solidFill>
                 <a:latin typeface="Arial"/>
               </a:rPr>
-              <a:t>Source: README section 2 (Utusan, ALNAP, ACFE); redteam/results/final/summary.json</a:t>
+              <a:t>Source: README section 2 (Utusan, ALNAP, ACFE); redteam/results/final/summary.json; redteam/results/variants-stage1/results.jsonl</a:t>
             </a:r>
           </a:p>
         </p:txBody>
@@ -11178,7 +11178,7 @@
                           </a:solidFill>
                           <a:latin typeface="Arial"/>
                         </a:rPr>
-                        <a:t>payment attacks signed</a:t>
+                        <a:t>payment attacks that got through</a:t>
                       </a:r>
                     </a:p>
                   </a:txBody>
@@ -11200,7 +11200,7 @@
                           </a:solidFill>
                           <a:latin typeface="Arial"/>
                         </a:rPr>
-                        <a:t>3 of 40</a:t>
+                        <a:t>13 of 312</a:t>
                       </a:r>
                     </a:p>
                   </a:txBody>
@@ -11222,7 +11222,7 @@
                           </a:solidFill>
                           <a:latin typeface="Arial"/>
                         </a:rPr>
-                        <a:t>0 of 40</a:t>
+                        <a:t>0 of 312</a:t>
                       </a:r>
                     </a:p>
                   </a:txBody>

</xml_diff>

<commit_message>
Deck: slide 14 says what we will show if we reach the final; slide 5 opens with what no other agent wallet we know of does
</commit_message>
<xml_diff>
--- a/docs/deck/amanah-deck.pptx
+++ b/docs/deck/amanah-deck.pptx
@@ -866,7 +866,7 @@
           <a:lstStyle/>
           <a:p>
             <a:r>
-              <a:t>Every security design has limits, and we would rather name ours first. The vault trusts the model family the trustees declare for each key; attestation is the next step. Two colluding trustees could defeat the bound. Forty-four seeds was a small red team; 300 random rewordings of them moved nothing through Amanah, but they test the same ideas. And our Qwen auditor sometimes stops a sound payout and asks for a person: that costs a delay, never a wrong payment. Next we attest each signer's model, grow the red team past one hundred and fifty adaptive attacks, add eligibility by proof with WeIdentity, and pilot one programme with a Malaysian zakat institution.</a:t>
+              <a:t>Every security design has limits, and we would rather name ours first. The vault trusts the model family the trustees declare for each key; attestation is the next step. Two colluding trustees could defeat the bound. Forty-four seeds was a small red team; 300 random rewordings of them moved nothing through Amanah, but they test the same ideas. And our Qwen auditor sometimes stops a sound payout and asks for a person: that costs a delay, never a wrong payment. If we reach the final, we will show four things working on the same public chain: each signer's model attested, an adaptive red team of one hundred and fifty attacks or more judged per attack idea, the auditor's rule tuned and its false stops measured again, and a live system anyone can attack. And we will bring a pilot plan for one zakat programme.</a:t>
             </a:r>
           </a:p>
         </p:txBody>
@@ -11889,7 +11889,7 @@
                 </a:solidFill>
                 <a:latin typeface="Arial"/>
               </a:rPr>
-              <a:t>Next steps</a:t>
+              <a:t>If We Reach the Final</a:t>
             </a:r>
           </a:p>
           <a:p>
@@ -11908,7 +11908,7 @@
                 </a:solidFill>
                 <a:latin typeface="Arial"/>
               </a:rPr>
-              <a:t>Attested lineage, in ERC-8004's Validation Registry</a:t>
+              <a:t>Attested model lineage, in ERC-8004's Validation Registry</a:t>
             </a:r>
           </a:p>
           <a:p>
@@ -11927,7 +11927,7 @@
                 </a:solidFill>
                 <a:latin typeface="Arial"/>
               </a:rPr>
-              <a:t>An adaptive red team of 150 or more payment attacks</a:t>
+              <a:t>An adaptive red team of 150 or more payment attacks, judged per attack idea</a:t>
             </a:r>
           </a:p>
           <a:p>
@@ -11946,7 +11946,7 @@
                 </a:solidFill>
                 <a:latin typeface="Arial"/>
               </a:rPr>
-              <a:t>Eligibility by proof: WeIdentity credentials, zero knowledge</a:t>
+              <a:t>The auditor's rule tuned on a fresh set, its false stops measured again</a:t>
             </a:r>
           </a:p>
           <a:p>
@@ -11965,7 +11965,7 @@
                 </a:solidFill>
                 <a:latin typeface="Arial"/>
               </a:rPr>
-              <a:t>A third model family, so a quorum can lose one provider</a:t>
+              <a:t>A live hosted system that anyone can attack</a:t>
             </a:r>
           </a:p>
           <a:p>
@@ -11984,7 +11984,7 @@
                 </a:solidFill>
                 <a:latin typeface="Arial"/>
               </a:rPr>
-              <a:t>A pilot with a Malaysian zakat institution</a:t>
+              <a:t>A pilot plan for one Malaysian zakat programme</a:t>
             </a:r>
           </a:p>
         </p:txBody>
@@ -15571,13 +15571,13 @@
               </a:spcAft>
             </a:pPr>
             <a:r>
-              <a:rPr sz="1500" b="0">
+              <a:rPr sz="1400" b="0">
                 <a:solidFill>
                   <a:srgbClr val="1B2333"/>
                 </a:solidFill>
                 <a:latin typeface="Arial"/>
               </a:rPr>
-              <a:t>Knight and Leveson (1986): independently written versions still fail together on the same hard inputs. Amanah gives its versions different inputs, not just different authors.</a:t>
+              <a:t>No other agent wallet we know of does this: the contract itself checks that the signers differ, and refuses two of one model family on a public chain. Knight and Leveson (1986) showed that independent versions still fail together, so Amanah also gives its signers different inputs.</a:t>
             </a:r>
           </a:p>
         </p:txBody>

</xml_diff>